<commit_message>
Clarify 59-photo review and YOLO evaluation in Ass5
</commit_message>
<xml_diff>
--- a/ass5_output/Residential_Intelligence_Project_Progress_READY_2026-10-18.pptx
+++ b/ass5_output/Residential_Intelligence_Project_Progress_READY_2026-10-18.pptx
@@ -4351,7 +4351,7 @@
               </a:defRPr>
             </a:pPr>
             <a:r>
-              <a:t>ความคืบหน้าที่เพิ่มจากกรอบแนวคิด</a:t>
+              <a:t>ภาพ 59 ใบถูกใช้ทำอะไรบ้าง?</a:t>
             </a:r>
           </a:p>
         </p:txBody>
@@ -4390,7 +4390,7 @@
               </a:defRPr>
             </a:pPr>
             <a:r>
-              <a:t>รับภาพจริงและคัดชุดใบซื้อสินค้าเพื่อเริ่มการทดลอง</a:t>
+              <a:t>ตรวจข้อมูลภาพครบชุด แล้วแยกภาพตามความเหมาะสมของการทดลอง YOLO</a:t>
             </a:r>
           </a:p>
         </p:txBody>
@@ -4779,31 +4779,113 @@
       </p:cxnSp>
       <p:sp>
         <p:nvSpPr>
-          <p:cNvPr id="14" name="TextBox 13"/>
-          <p:cNvSpPr txBox="1"/>
-          <p:nvPr/>
-        </p:nvSpPr>
-        <p:spPr>
-          <a:xfrm>
-            <a:off x="832104" y="3712463"/>
-            <a:ext cx="10424160" cy="868680"/>
-          </a:xfrm>
-          <a:prstGeom prst="rect">
-            <a:avLst/>
-          </a:prstGeom>
-          <a:noFill/>
-        </p:spPr>
-        <p:txBody>
-          <a:bodyPr wrap="square" lIns="18288" rIns="18288" tIns="0" bIns="0">
-            <a:spAutoFit/>
-          </a:bodyPr>
-          <a:lstStyle/>
-          <a:p>
-            <a:pPr algn="l">
-              <a:spcAft>
-                <a:spcPts val="400"/>
-              </a:spcAft>
-              <a:defRPr sz="2100" b="1">
+          <p:cNvPr id="14" name="Rounded Rectangle 13"/>
+          <p:cNvSpPr/>
+          <p:nvPr/>
+        </p:nvSpPr>
+        <p:spPr>
+          <a:xfrm>
+            <a:off x="777240" y="3685032"/>
+            <a:ext cx="3456432" cy="1335024"/>
+          </a:xfrm>
+          <a:prstGeom prst="roundRect">
+            <a:avLst/>
+          </a:prstGeom>
+          <a:solidFill>
+            <a:srgbClr val="F2F6F8"/>
+          </a:solidFill>
+          <a:ln>
+            <a:noFill/>
+          </a:ln>
+        </p:spPr>
+        <p:style>
+          <a:lnRef idx="1">
+            <a:schemeClr val="accent1"/>
+          </a:lnRef>
+          <a:fillRef idx="3">
+            <a:schemeClr val="accent1"/>
+          </a:fillRef>
+          <a:effectRef idx="2">
+            <a:schemeClr val="accent1"/>
+          </a:effectRef>
+          <a:fontRef idx="minor">
+            <a:schemeClr val="lt1"/>
+          </a:fontRef>
+        </p:style>
+        <p:txBody>
+          <a:bodyPr rtlCol="0" anchor="ctr"/>
+          <a:lstStyle/>
+          <a:p>
+            <a:pPr algn="ctr"/>
+          </a:p>
+        </p:txBody>
+      </p:sp>
+      <p:sp>
+        <p:nvSpPr>
+          <p:cNvPr id="15" name="TextBox 14"/>
+          <p:cNvSpPr txBox="1"/>
+          <p:nvPr/>
+        </p:nvSpPr>
+        <p:spPr>
+          <a:xfrm>
+            <a:off x="932688" y="3840480"/>
+            <a:ext cx="731520" cy="521207"/>
+          </a:xfrm>
+          <a:prstGeom prst="rect">
+            <a:avLst/>
+          </a:prstGeom>
+          <a:noFill/>
+        </p:spPr>
+        <p:txBody>
+          <a:bodyPr wrap="square" lIns="18288" rIns="18288" tIns="0" bIns="0">
+            <a:spAutoFit/>
+          </a:bodyPr>
+          <a:lstStyle/>
+          <a:p>
+            <a:pPr algn="l">
+              <a:spcAft>
+                <a:spcPts val="400"/>
+              </a:spcAft>
+              <a:defRPr sz="3000" b="1">
+                <a:solidFill>
+                  <a:srgbClr val="006289"/>
+                </a:solidFill>
+                <a:latin typeface="Tahoma"/>
+              </a:defRPr>
+            </a:pPr>
+            <a:r>
+              <a:t>48</a:t>
+            </a:r>
+          </a:p>
+        </p:txBody>
+      </p:sp>
+      <p:sp>
+        <p:nvSpPr>
+          <p:cNvPr id="16" name="TextBox 15"/>
+          <p:cNvSpPr txBox="1"/>
+          <p:nvPr/>
+        </p:nvSpPr>
+        <p:spPr>
+          <a:xfrm>
+            <a:off x="1737360" y="3785615"/>
+            <a:ext cx="2340863" cy="365760"/>
+          </a:xfrm>
+          <a:prstGeom prst="rect">
+            <a:avLst/>
+          </a:prstGeom>
+          <a:noFill/>
+        </p:spPr>
+        <p:txBody>
+          <a:bodyPr wrap="square" lIns="18288" rIns="18288" tIns="0" bIns="0">
+            <a:spAutoFit/>
+          </a:bodyPr>
+          <a:lstStyle/>
+          <a:p>
+            <a:pPr algn="l">
+              <a:spcAft>
+                <a:spcPts val="400"/>
+              </a:spcAft>
+              <a:defRPr sz="1900" b="1">
                 <a:solidFill>
                   <a:srgbClr val="1D2A5D"/>
                 </a:solidFill>
@@ -4811,38 +4893,436 @@
               </a:defRPr>
             </a:pPr>
             <a:r>
-              <a:t>จาก 59 ภาพ แยกทดลองตัวตรวจจับ 48 ภาพฉากเดิม (38 ฝึก / 10 ตรวจ) และ 6 ภาพต่างฉาก; อีก 5 ภาพกันออก</a:t>
-            </a:r>
-          </a:p>
-        </p:txBody>
-      </p:sp>
-      <p:sp>
-        <p:nvSpPr>
-          <p:cNvPr id="15" name="TextBox 14"/>
-          <p:cNvSpPr txBox="1"/>
-          <p:nvPr/>
-        </p:nvSpPr>
-        <p:spPr>
-          <a:xfrm>
-            <a:off x="832104" y="5020056"/>
-            <a:ext cx="10149840" cy="612648"/>
-          </a:xfrm>
-          <a:prstGeom prst="rect">
-            <a:avLst/>
-          </a:prstGeom>
-          <a:noFill/>
-        </p:spPr>
-        <p:txBody>
-          <a:bodyPr wrap="square" lIns="18288" rIns="18288" tIns="0" bIns="0">
-            <a:spAutoFit/>
-          </a:bodyPr>
-          <a:lstStyle/>
-          <a:p>
-            <a:pPr algn="l">
-              <a:spcAft>
-                <a:spcPts val="400"/>
-              </a:spcAft>
-              <a:defRPr sz="1600" b="0">
+              <a:t>ภาพชุดแรก</a:t>
+            </a:r>
+          </a:p>
+        </p:txBody>
+      </p:sp>
+      <p:sp>
+        <p:nvSpPr>
+          <p:cNvPr id="17" name="TextBox 16"/>
+          <p:cNvSpPr txBox="1"/>
+          <p:nvPr/>
+        </p:nvSpPr>
+        <p:spPr>
+          <a:xfrm>
+            <a:off x="1737360" y="4297680"/>
+            <a:ext cx="2331720" cy="448056"/>
+          </a:xfrm>
+          <a:prstGeom prst="rect">
+            <a:avLst/>
+          </a:prstGeom>
+          <a:noFill/>
+        </p:spPr>
+        <p:txBody>
+          <a:bodyPr wrap="square" lIns="18288" rIns="18288" tIns="0" bIns="0">
+            <a:spAutoFit/>
+          </a:bodyPr>
+          <a:lstStyle/>
+          <a:p>
+            <a:pPr algn="l">
+              <a:spcAft>
+                <a:spcPts val="400"/>
+              </a:spcAft>
+              <a:defRPr sz="1500" b="0">
+                <a:solidFill>
+                  <a:srgbClr val="1D2F3E"/>
+                </a:solidFill>
+                <a:latin typeface="Tahoma"/>
+              </a:defRPr>
+            </a:pPr>
+            <a:r>
+              <a:t>38 ฝึก + 10 ตรวจ</a:t>
+            </a:r>
+          </a:p>
+        </p:txBody>
+      </p:sp>
+      <p:sp>
+        <p:nvSpPr>
+          <p:cNvPr id="18" name="Rounded Rectangle 17"/>
+          <p:cNvSpPr/>
+          <p:nvPr/>
+        </p:nvSpPr>
+        <p:spPr>
+          <a:xfrm>
+            <a:off x="4370832" y="3685032"/>
+            <a:ext cx="3456432" cy="1335024"/>
+          </a:xfrm>
+          <a:prstGeom prst="roundRect">
+            <a:avLst/>
+          </a:prstGeom>
+          <a:solidFill>
+            <a:srgbClr val="F2F6F8"/>
+          </a:solidFill>
+          <a:ln>
+            <a:noFill/>
+          </a:ln>
+        </p:spPr>
+        <p:style>
+          <a:lnRef idx="1">
+            <a:schemeClr val="accent1"/>
+          </a:lnRef>
+          <a:fillRef idx="3">
+            <a:schemeClr val="accent1"/>
+          </a:fillRef>
+          <a:effectRef idx="2">
+            <a:schemeClr val="accent1"/>
+          </a:effectRef>
+          <a:fontRef idx="minor">
+            <a:schemeClr val="lt1"/>
+          </a:fontRef>
+        </p:style>
+        <p:txBody>
+          <a:bodyPr rtlCol="0" anchor="ctr"/>
+          <a:lstStyle/>
+          <a:p>
+            <a:pPr algn="ctr"/>
+          </a:p>
+        </p:txBody>
+      </p:sp>
+      <p:sp>
+        <p:nvSpPr>
+          <p:cNvPr id="19" name="TextBox 18"/>
+          <p:cNvSpPr txBox="1"/>
+          <p:nvPr/>
+        </p:nvSpPr>
+        <p:spPr>
+          <a:xfrm>
+            <a:off x="4526280" y="3840480"/>
+            <a:ext cx="731520" cy="521207"/>
+          </a:xfrm>
+          <a:prstGeom prst="rect">
+            <a:avLst/>
+          </a:prstGeom>
+          <a:noFill/>
+        </p:spPr>
+        <p:txBody>
+          <a:bodyPr wrap="square" lIns="18288" rIns="18288" tIns="0" bIns="0">
+            <a:spAutoFit/>
+          </a:bodyPr>
+          <a:lstStyle/>
+          <a:p>
+            <a:pPr algn="l">
+              <a:spcAft>
+                <a:spcPts val="400"/>
+              </a:spcAft>
+              <a:defRPr sz="3000" b="1">
+                <a:solidFill>
+                  <a:srgbClr val="006289"/>
+                </a:solidFill>
+                <a:latin typeface="Tahoma"/>
+              </a:defRPr>
+            </a:pPr>
+            <a:r>
+              <a:t>6</a:t>
+            </a:r>
+          </a:p>
+        </p:txBody>
+      </p:sp>
+      <p:sp>
+        <p:nvSpPr>
+          <p:cNvPr id="20" name="TextBox 19"/>
+          <p:cNvSpPr txBox="1"/>
+          <p:nvPr/>
+        </p:nvSpPr>
+        <p:spPr>
+          <a:xfrm>
+            <a:off x="5330952" y="3785615"/>
+            <a:ext cx="2340863" cy="365760"/>
+          </a:xfrm>
+          <a:prstGeom prst="rect">
+            <a:avLst/>
+          </a:prstGeom>
+          <a:noFill/>
+        </p:spPr>
+        <p:txBody>
+          <a:bodyPr wrap="square" lIns="18288" rIns="18288" tIns="0" bIns="0">
+            <a:spAutoFit/>
+          </a:bodyPr>
+          <a:lstStyle/>
+          <a:p>
+            <a:pPr algn="l">
+              <a:spcAft>
+                <a:spcPts val="400"/>
+              </a:spcAft>
+              <a:defRPr sz="1900" b="1">
+                <a:solidFill>
+                  <a:srgbClr val="1D2A5D"/>
+                </a:solidFill>
+                <a:latin typeface="Tahoma"/>
+              </a:defRPr>
+            </a:pPr>
+            <a:r>
+              <a:t>ภาพฉากใหม่</a:t>
+            </a:r>
+          </a:p>
+        </p:txBody>
+      </p:sp>
+      <p:sp>
+        <p:nvSpPr>
+          <p:cNvPr id="21" name="TextBox 20"/>
+          <p:cNvSpPr txBox="1"/>
+          <p:nvPr/>
+        </p:nvSpPr>
+        <p:spPr>
+          <a:xfrm>
+            <a:off x="5330952" y="4297680"/>
+            <a:ext cx="2331720" cy="448056"/>
+          </a:xfrm>
+          <a:prstGeom prst="rect">
+            <a:avLst/>
+          </a:prstGeom>
+          <a:noFill/>
+        </p:spPr>
+        <p:txBody>
+          <a:bodyPr wrap="square" lIns="18288" rIns="18288" tIns="0" bIns="0">
+            <a:spAutoFit/>
+          </a:bodyPr>
+          <a:lstStyle/>
+          <a:p>
+            <a:pPr algn="l">
+              <a:spcAft>
+                <a:spcPts val="400"/>
+              </a:spcAft>
+              <a:defRPr sz="1500" b="0">
+                <a:solidFill>
+                  <a:srgbClr val="1D2F3E"/>
+                </a:solidFill>
+                <a:latin typeface="Tahoma"/>
+              </a:defRPr>
+            </a:pPr>
+            <a:r>
+              <a:t>ทดสอบโมเดลเดิม</a:t>
+            </a:r>
+          </a:p>
+        </p:txBody>
+      </p:sp>
+      <p:sp>
+        <p:nvSpPr>
+          <p:cNvPr id="22" name="Rounded Rectangle 21"/>
+          <p:cNvSpPr/>
+          <p:nvPr/>
+        </p:nvSpPr>
+        <p:spPr>
+          <a:xfrm>
+            <a:off x="7964424" y="3685032"/>
+            <a:ext cx="3456432" cy="1335024"/>
+          </a:xfrm>
+          <a:prstGeom prst="roundRect">
+            <a:avLst/>
+          </a:prstGeom>
+          <a:solidFill>
+            <a:srgbClr val="F2F6F8"/>
+          </a:solidFill>
+          <a:ln>
+            <a:noFill/>
+          </a:ln>
+        </p:spPr>
+        <p:style>
+          <a:lnRef idx="1">
+            <a:schemeClr val="accent1"/>
+          </a:lnRef>
+          <a:fillRef idx="3">
+            <a:schemeClr val="accent1"/>
+          </a:fillRef>
+          <a:effectRef idx="2">
+            <a:schemeClr val="accent1"/>
+          </a:effectRef>
+          <a:fontRef idx="minor">
+            <a:schemeClr val="lt1"/>
+          </a:fontRef>
+        </p:style>
+        <p:txBody>
+          <a:bodyPr rtlCol="0" anchor="ctr"/>
+          <a:lstStyle/>
+          <a:p>
+            <a:pPr algn="ctr"/>
+          </a:p>
+        </p:txBody>
+      </p:sp>
+      <p:sp>
+        <p:nvSpPr>
+          <p:cNvPr id="23" name="TextBox 22"/>
+          <p:cNvSpPr txBox="1"/>
+          <p:nvPr/>
+        </p:nvSpPr>
+        <p:spPr>
+          <a:xfrm>
+            <a:off x="8119872" y="3840480"/>
+            <a:ext cx="731520" cy="521207"/>
+          </a:xfrm>
+          <a:prstGeom prst="rect">
+            <a:avLst/>
+          </a:prstGeom>
+          <a:noFill/>
+        </p:spPr>
+        <p:txBody>
+          <a:bodyPr wrap="square" lIns="18288" rIns="18288" tIns="0" bIns="0">
+            <a:spAutoFit/>
+          </a:bodyPr>
+          <a:lstStyle/>
+          <a:p>
+            <a:pPr algn="l">
+              <a:spcAft>
+                <a:spcPts val="400"/>
+              </a:spcAft>
+              <a:defRPr sz="3000" b="1">
+                <a:solidFill>
+                  <a:srgbClr val="C05C2B"/>
+                </a:solidFill>
+                <a:latin typeface="Tahoma"/>
+              </a:defRPr>
+            </a:pPr>
+            <a:r>
+              <a:t>5</a:t>
+            </a:r>
+          </a:p>
+        </p:txBody>
+      </p:sp>
+      <p:sp>
+        <p:nvSpPr>
+          <p:cNvPr id="24" name="TextBox 23"/>
+          <p:cNvSpPr txBox="1"/>
+          <p:nvPr/>
+        </p:nvSpPr>
+        <p:spPr>
+          <a:xfrm>
+            <a:off x="8924544" y="3785615"/>
+            <a:ext cx="2340863" cy="365760"/>
+          </a:xfrm>
+          <a:prstGeom prst="rect">
+            <a:avLst/>
+          </a:prstGeom>
+          <a:noFill/>
+        </p:spPr>
+        <p:txBody>
+          <a:bodyPr wrap="square" lIns="18288" rIns="18288" tIns="0" bIns="0">
+            <a:spAutoFit/>
+          </a:bodyPr>
+          <a:lstStyle/>
+          <a:p>
+            <a:pPr algn="l">
+              <a:spcAft>
+                <a:spcPts val="400"/>
+              </a:spcAft>
+              <a:defRPr sz="1900" b="1">
+                <a:solidFill>
+                  <a:srgbClr val="1D2A5D"/>
+                </a:solidFill>
+                <a:latin typeface="Tahoma"/>
+              </a:defRPr>
+            </a:pPr>
+            <a:r>
+              <a:t>ภาพกันออก</a:t>
+            </a:r>
+          </a:p>
+        </p:txBody>
+      </p:sp>
+      <p:sp>
+        <p:nvSpPr>
+          <p:cNvPr id="25" name="TextBox 24"/>
+          <p:cNvSpPr txBox="1"/>
+          <p:nvPr/>
+        </p:nvSpPr>
+        <p:spPr>
+          <a:xfrm>
+            <a:off x="8924544" y="4297680"/>
+            <a:ext cx="2331720" cy="448056"/>
+          </a:xfrm>
+          <a:prstGeom prst="rect">
+            <a:avLst/>
+          </a:prstGeom>
+          <a:noFill/>
+        </p:spPr>
+        <p:txBody>
+          <a:bodyPr wrap="square" lIns="18288" rIns="18288" tIns="0" bIns="0">
+            <a:spAutoFit/>
+          </a:bodyPr>
+          <a:lstStyle/>
+          <a:p>
+            <a:pPr algn="l">
+              <a:spcAft>
+                <a:spcPts val="400"/>
+              </a:spcAft>
+              <a:defRPr sz="1500" b="0">
+                <a:solidFill>
+                  <a:srgbClr val="1D2F3E"/>
+                </a:solidFill>
+                <a:latin typeface="Tahoma"/>
+              </a:defRPr>
+            </a:pPr>
+            <a:r>
+              <a:t>หลายเอกสาร/เสี่ยงใกล้ซ้ำ</a:t>
+            </a:r>
+          </a:p>
+        </p:txBody>
+      </p:sp>
+      <p:sp>
+        <p:nvSpPr>
+          <p:cNvPr id="26" name="TextBox 25"/>
+          <p:cNvSpPr txBox="1"/>
+          <p:nvPr/>
+        </p:nvSpPr>
+        <p:spPr>
+          <a:xfrm>
+            <a:off x="795528" y="5413248"/>
+            <a:ext cx="10698480" cy="502920"/>
+          </a:xfrm>
+          <a:prstGeom prst="rect">
+            <a:avLst/>
+          </a:prstGeom>
+          <a:noFill/>
+        </p:spPr>
+        <p:txBody>
+          <a:bodyPr wrap="square" lIns="18288" rIns="18288" tIns="0" bIns="0">
+            <a:spAutoFit/>
+          </a:bodyPr>
+          <a:lstStyle/>
+          <a:p>
+            <a:pPr algn="l">
+              <a:spcAft>
+                <a:spcPts val="400"/>
+              </a:spcAft>
+              <a:defRPr sz="1700" b="1">
+                <a:solidFill>
+                  <a:srgbClr val="1D2A5D"/>
+                </a:solidFill>
+                <a:latin typeface="Tahoma"/>
+              </a:defRPr>
+            </a:pPr>
+            <a:r>
+              <a:t>ตรวจข้อมูล/ทิศภาพครบ 59 ใบ; คะแนน YOLO หน้าถัดไปมาจากภาพตรวจ 10 + 6 ใบ ไม่ใช่คะแนนทั้ง 59 ใบ</a:t>
+            </a:r>
+          </a:p>
+        </p:txBody>
+      </p:sp>
+      <p:sp>
+        <p:nvSpPr>
+          <p:cNvPr id="27" name="TextBox 26"/>
+          <p:cNvSpPr txBox="1"/>
+          <p:nvPr/>
+        </p:nvSpPr>
+        <p:spPr>
+          <a:xfrm>
+            <a:off x="804672" y="5925312"/>
+            <a:ext cx="10241280" cy="320040"/>
+          </a:xfrm>
+          <a:prstGeom prst="rect">
+            <a:avLst/>
+          </a:prstGeom>
+          <a:noFill/>
+        </p:spPr>
+        <p:txBody>
+          <a:bodyPr wrap="square" lIns="18288" rIns="18288" tIns="0" bIns="0">
+            <a:spAutoFit/>
+          </a:bodyPr>
+          <a:lstStyle/>
+          <a:p>
+            <a:pPr algn="l">
+              <a:spcAft>
+                <a:spcPts val="400"/>
+              </a:spcAft>
+              <a:defRPr sz="1400" b="0">
                 <a:solidFill>
                   <a:srgbClr val="576975"/>
                 </a:solidFill>
@@ -4850,7 +5330,7 @@
               </a:defRPr>
             </a:pPr>
             <a:r>
-              <a:t>จำนวนภาพไม่เท่ากับจำนวนธุรกรรมอิสระ; ประเภทภาพและกรอบอ้างอิงยังต้องให้ผู้วิจัยตรวจซ้ำ</a:t>
+              <a:t>59 ภาพยังไม่เท่ากับ 59 ธุรกรรมอิสระ</a:t>
             </a:r>
           </a:p>
         </p:txBody>
@@ -4915,7 +5395,7 @@
               </a:defRPr>
             </a:pPr>
             <a:r>
-              <a:t>สำรวจภาพใบซื้อสินค้า 59 ภาพ</a:t>
+              <a:t>ตรวจภาพใบซื้อสินค้า 59 ภาพครบชุด</a:t>
             </a:r>
           </a:p>
         </p:txBody>
@@ -4954,7 +5434,7 @@
               </a:defRPr>
             </a:pPr>
             <a:r>
-              <a:t>ผล EDA ช่วยระบุความหลากหลายที่ต้องเพิ่มก่อนทดสอบจริง</a:t>
+              <a:t>ข้อมูลภาพและทิศตัวหนังสือครบทุกภาพ; การถอดชื่อสินค้ายังมีข้อจำกัด</a:t>
             </a:r>
           </a:p>
         </p:txBody>
@@ -5143,33 +5623,33 @@
         </p:nvSpPr>
         <p:spPr>
           <a:xfrm>
-            <a:off x="758952" y="5742432"/>
-            <a:ext cx="10744200" cy="310896"/>
-          </a:xfrm>
-          <a:prstGeom prst="rect">
-            <a:avLst/>
-          </a:prstGeom>
-          <a:noFill/>
-        </p:spPr>
-        <p:txBody>
-          <a:bodyPr wrap="square" lIns="18288" rIns="18288" tIns="0" bIns="0">
-            <a:spAutoFit/>
-          </a:bodyPr>
-          <a:lstStyle/>
-          <a:p>
-            <a:pPr algn="l">
-              <a:spcAft>
-                <a:spcPts val="400"/>
-              </a:spcAft>
-              <a:defRPr sz="1400" b="0">
-                <a:solidFill>
-                  <a:srgbClr val="576975"/>
-                </a:solidFill>
-                <a:latin typeface="Tahoma"/>
-              </a:defRPr>
-            </a:pPr>
-            <a:r>
-              <a:t>ตรวจทิศตัวหนังสือครบ 59 ภาพ: อ่านตรงเดิม 41 / ตะแคง 18; ค่าความสว่างรวมพื้นหลัง</a:t>
+            <a:off x="758952" y="5733288"/>
+            <a:ext cx="10744200" cy="347472"/>
+          </a:xfrm>
+          <a:prstGeom prst="rect">
+            <a:avLst/>
+          </a:prstGeom>
+          <a:noFill/>
+        </p:spPr>
+        <p:txBody>
+          <a:bodyPr wrap="square" lIns="18288" rIns="18288" tIns="0" bIns="0">
+            <a:spAutoFit/>
+          </a:bodyPr>
+          <a:lstStyle/>
+          <a:p>
+            <a:pPr algn="l">
+              <a:spcAft>
+                <a:spcPts val="400"/>
+              </a:spcAft>
+              <a:defRPr sz="1600" b="1">
+                <a:solidFill>
+                  <a:srgbClr val="1D2A5D"/>
+                </a:solidFill>
+                <a:latin typeface="Tahoma"/>
+              </a:defRPr>
+            </a:pPr>
+            <a:r>
+              <a:t>ตรวจทั้ง 59 ภาพแล้ว: ชื่อสินค้าถอดครบ 12 | อ่านได้บางส่วน 45 | ไม่มีบรรทัดชื่อ 2</a:t>
             </a:r>
           </a:p>
         </p:txBody>
@@ -5234,7 +5714,7 @@
               </a:defRPr>
             </a:pPr>
             <a:r>
-              <a:t>ผลนำร่อง YOLOv8n: สองชุดภาพให้คะแนนต่างกัน</a:t>
+              <a:t>ตรวจภาพทั้ง 59 ใบแล้ว ได้ข้อมูลชื่อสินค้าแค่ไหน?</a:t>
             </a:r>
           </a:p>
         </p:txBody>
@@ -5273,7 +5753,7 @@
               </a:defRPr>
             </a:pPr>
             <a:r>
-              <a:t>โมเดลเดียวกัน ฝึกบน PC CPU; mAP@0.5 วัดการตรวจจับกรอบใบซื้อสินค้า</a:t>
+              <a:t>นับเฉพาะชื่อสินค้าบนบรรทัดรายการ; ตรวจด้วยตาครั้งแรกทุกภาพ</a:t>
             </a:r>
           </a:p>
         </p:txBody>
@@ -5393,176 +5873,20 @@
       </p:sp>
       <p:sp>
         <p:nvSpPr>
-          <p:cNvPr id="7" name="TextBox 6"/>
-          <p:cNvSpPr txBox="1"/>
-          <p:nvPr/>
-        </p:nvSpPr>
-        <p:spPr>
-          <a:xfrm>
-            <a:off x="877824" y="1709928"/>
-            <a:ext cx="4297680" cy="1024128"/>
-          </a:xfrm>
-          <a:prstGeom prst="rect">
-            <a:avLst/>
-          </a:prstGeom>
-          <a:noFill/>
-        </p:spPr>
-        <p:txBody>
-          <a:bodyPr wrap="square" lIns="18288" rIns="18288" tIns="0" bIns="0">
-            <a:spAutoFit/>
-          </a:bodyPr>
-          <a:lstStyle/>
-          <a:p>
-            <a:pPr algn="l">
-              <a:spcAft>
-                <a:spcPts val="400"/>
-              </a:spcAft>
-              <a:defRPr sz="5000" b="1">
-                <a:solidFill>
-                  <a:srgbClr val="137E9A"/>
-                </a:solidFill>
-                <a:latin typeface="Tahoma"/>
-              </a:defRPr>
-            </a:pPr>
-            <a:r>
-              <a:t>0.928</a:t>
-            </a:r>
-          </a:p>
-        </p:txBody>
-      </p:sp>
-      <p:sp>
-        <p:nvSpPr>
-          <p:cNvPr id="8" name="TextBox 7"/>
-          <p:cNvSpPr txBox="1"/>
-          <p:nvPr/>
-        </p:nvSpPr>
-        <p:spPr>
-          <a:xfrm>
-            <a:off x="905256" y="2770632"/>
-            <a:ext cx="4389120" cy="411480"/>
-          </a:xfrm>
-          <a:prstGeom prst="rect">
-            <a:avLst/>
-          </a:prstGeom>
-          <a:noFill/>
-        </p:spPr>
-        <p:txBody>
-          <a:bodyPr wrap="square" lIns="18288" rIns="18288" tIns="0" bIns="0">
-            <a:spAutoFit/>
-          </a:bodyPr>
-          <a:lstStyle/>
-          <a:p>
-            <a:pPr algn="l">
-              <a:spcAft>
-                <a:spcPts val="400"/>
-              </a:spcAft>
-              <a:defRPr sz="2000" b="1">
-                <a:solidFill>
-                  <a:srgbClr val="1D2F3E"/>
-                </a:solidFill>
-                <a:latin typeface="Tahoma"/>
-              </a:defRPr>
-            </a:pPr>
-            <a:r>
-              <a:t>ตรวจ 10 ภาพจากชุดแรก</a:t>
-            </a:r>
-          </a:p>
-        </p:txBody>
-      </p:sp>
-      <p:sp>
-        <p:nvSpPr>
-          <p:cNvPr id="9" name="TextBox 8"/>
-          <p:cNvSpPr txBox="1"/>
-          <p:nvPr/>
-        </p:nvSpPr>
-        <p:spPr>
-          <a:xfrm>
-            <a:off x="6455664" y="1709928"/>
-            <a:ext cx="4389120" cy="1024128"/>
-          </a:xfrm>
-          <a:prstGeom prst="rect">
-            <a:avLst/>
-          </a:prstGeom>
-          <a:noFill/>
-        </p:spPr>
-        <p:txBody>
-          <a:bodyPr wrap="square" lIns="18288" rIns="18288" tIns="0" bIns="0">
-            <a:spAutoFit/>
-          </a:bodyPr>
-          <a:lstStyle/>
-          <a:p>
-            <a:pPr algn="l">
-              <a:spcAft>
-                <a:spcPts val="400"/>
-              </a:spcAft>
-              <a:defRPr sz="5000" b="1">
-                <a:solidFill>
-                  <a:srgbClr val="C05C2B"/>
-                </a:solidFill>
-                <a:latin typeface="Tahoma"/>
-              </a:defRPr>
-            </a:pPr>
-            <a:r>
-              <a:t>0.237</a:t>
-            </a:r>
-          </a:p>
-        </p:txBody>
-      </p:sp>
-      <p:sp>
-        <p:nvSpPr>
-          <p:cNvPr id="10" name="TextBox 9"/>
-          <p:cNvSpPr txBox="1"/>
-          <p:nvPr/>
-        </p:nvSpPr>
-        <p:spPr>
-          <a:xfrm>
-            <a:off x="6492240" y="2770632"/>
-            <a:ext cx="4462272" cy="411480"/>
-          </a:xfrm>
-          <a:prstGeom prst="rect">
-            <a:avLst/>
-          </a:prstGeom>
-          <a:noFill/>
-        </p:spPr>
-        <p:txBody>
-          <a:bodyPr wrap="square" lIns="18288" rIns="18288" tIns="0" bIns="0">
-            <a:spAutoFit/>
-          </a:bodyPr>
-          <a:lstStyle/>
-          <a:p>
-            <a:pPr algn="l">
-              <a:spcAft>
-                <a:spcPts val="400"/>
-              </a:spcAft>
-              <a:defRPr sz="2000" b="1">
-                <a:solidFill>
-                  <a:srgbClr val="1D2F3E"/>
-                </a:solidFill>
-                <a:latin typeface="Tahoma"/>
-              </a:defRPr>
-            </a:pPr>
-            <a:r>
-              <a:t>ภาพส่งเพิ่ม 6 ภาพ (ฉากใหม่)</a:t>
-            </a:r>
-          </a:p>
-        </p:txBody>
-      </p:sp>
-      <p:sp>
-        <p:nvSpPr>
-          <p:cNvPr id="11" name="Rectangle 10"/>
+          <p:cNvPr id="7" name="Rounded Rectangle 6"/>
           <p:cNvSpPr/>
           <p:nvPr/>
         </p:nvSpPr>
         <p:spPr>
           <a:xfrm>
-            <a:off x="914400" y="3611880"/>
-            <a:ext cx="9966960" cy="265176"/>
-          </a:xfrm>
-          <a:prstGeom prst="rect">
+            <a:off x="722376" y="1737360"/>
+            <a:ext cx="3282696" cy="3054096"/>
+          </a:xfrm>
+          <a:prstGeom prst="roundRect">
             <a:avLst/>
           </a:prstGeom>
           <a:solidFill>
-            <a:srgbClr val="E0E9EE"/>
+            <a:srgbClr val="F2F6F8"/>
           </a:solidFill>
           <a:ln>
             <a:noFill/>
@@ -5592,20 +5916,137 @@
       </p:sp>
       <p:sp>
         <p:nvSpPr>
-          <p:cNvPr id="12" name="Rectangle 11"/>
+          <p:cNvPr id="8" name="TextBox 7"/>
+          <p:cNvSpPr txBox="1"/>
+          <p:nvPr/>
+        </p:nvSpPr>
+        <p:spPr>
+          <a:xfrm>
+            <a:off x="950976" y="1993392"/>
+            <a:ext cx="2834640" cy="941832"/>
+          </a:xfrm>
+          <a:prstGeom prst="rect">
+            <a:avLst/>
+          </a:prstGeom>
+          <a:noFill/>
+        </p:spPr>
+        <p:txBody>
+          <a:bodyPr wrap="square" lIns="18288" rIns="18288" tIns="0" bIns="0">
+            <a:spAutoFit/>
+          </a:bodyPr>
+          <a:lstStyle/>
+          <a:p>
+            <a:pPr algn="l">
+              <a:spcAft>
+                <a:spcPts val="400"/>
+              </a:spcAft>
+              <a:defRPr sz="4900" b="1">
+                <a:solidFill>
+                  <a:srgbClr val="137E9A"/>
+                </a:solidFill>
+                <a:latin typeface="Tahoma"/>
+              </a:defRPr>
+            </a:pPr>
+            <a:r>
+              <a:t>12</a:t>
+            </a:r>
+          </a:p>
+        </p:txBody>
+      </p:sp>
+      <p:sp>
+        <p:nvSpPr>
+          <p:cNvPr id="9" name="TextBox 8"/>
+          <p:cNvSpPr txBox="1"/>
+          <p:nvPr/>
+        </p:nvSpPr>
+        <p:spPr>
+          <a:xfrm>
+            <a:off x="950976" y="3090672"/>
+            <a:ext cx="2816352" cy="466344"/>
+          </a:xfrm>
+          <a:prstGeom prst="rect">
+            <a:avLst/>
+          </a:prstGeom>
+          <a:noFill/>
+        </p:spPr>
+        <p:txBody>
+          <a:bodyPr wrap="square" lIns="18288" rIns="18288" tIns="0" bIns="0">
+            <a:spAutoFit/>
+          </a:bodyPr>
+          <a:lstStyle/>
+          <a:p>
+            <a:pPr algn="l">
+              <a:spcAft>
+                <a:spcPts val="400"/>
+              </a:spcAft>
+              <a:defRPr sz="2200" b="1">
+                <a:solidFill>
+                  <a:srgbClr val="1D2A5D"/>
+                </a:solidFill>
+                <a:latin typeface="Tahoma"/>
+              </a:defRPr>
+            </a:pPr>
+            <a:r>
+              <a:t>ถอดชื่อครบ</a:t>
+            </a:r>
+          </a:p>
+        </p:txBody>
+      </p:sp>
+      <p:sp>
+        <p:nvSpPr>
+          <p:cNvPr id="10" name="TextBox 9"/>
+          <p:cNvSpPr txBox="1"/>
+          <p:nvPr/>
+        </p:nvSpPr>
+        <p:spPr>
+          <a:xfrm>
+            <a:off x="950976" y="3703320"/>
+            <a:ext cx="2798064" cy="758952"/>
+          </a:xfrm>
+          <a:prstGeom prst="rect">
+            <a:avLst/>
+          </a:prstGeom>
+          <a:noFill/>
+        </p:spPr>
+        <p:txBody>
+          <a:bodyPr wrap="square" lIns="18288" rIns="18288" tIns="0" bIns="0">
+            <a:spAutoFit/>
+          </a:bodyPr>
+          <a:lstStyle/>
+          <a:p>
+            <a:pPr algn="l">
+              <a:spcAft>
+                <a:spcPts val="400"/>
+              </a:spcAft>
+              <a:defRPr sz="1600" b="0">
+                <a:solidFill>
+                  <a:srgbClr val="1D2F3E"/>
+                </a:solidFill>
+                <a:latin typeface="Tahoma"/>
+              </a:defRPr>
+            </a:pPr>
+            <a:r>
+              <a:t>ชื่อทุกบรรทัดที่เห็นอ่านได้</a:t>
+            </a:r>
+          </a:p>
+        </p:txBody>
+      </p:sp>
+      <p:sp>
+        <p:nvSpPr>
+          <p:cNvPr id="11" name="Rounded Rectangle 10"/>
           <p:cNvSpPr/>
           <p:nvPr/>
         </p:nvSpPr>
         <p:spPr>
           <a:xfrm>
-            <a:off x="914400" y="3611880"/>
-            <a:ext cx="9249338" cy="265176"/>
-          </a:xfrm>
-          <a:prstGeom prst="rect">
+            <a:off x="4443984" y="1737360"/>
+            <a:ext cx="3282696" cy="3054096"/>
+          </a:xfrm>
+          <a:prstGeom prst="roundRect">
             <a:avLst/>
           </a:prstGeom>
           <a:solidFill>
-            <a:srgbClr val="137E9A"/>
+            <a:srgbClr val="F2F6F8"/>
           </a:solidFill>
           <a:ln>
             <a:noFill/>
@@ -5635,20 +6076,137 @@
       </p:sp>
       <p:sp>
         <p:nvSpPr>
-          <p:cNvPr id="13" name="Rectangle 12"/>
+          <p:cNvPr id="12" name="TextBox 11"/>
+          <p:cNvSpPr txBox="1"/>
+          <p:nvPr/>
+        </p:nvSpPr>
+        <p:spPr>
+          <a:xfrm>
+            <a:off x="4672584" y="1993392"/>
+            <a:ext cx="2834640" cy="941832"/>
+          </a:xfrm>
+          <a:prstGeom prst="rect">
+            <a:avLst/>
+          </a:prstGeom>
+          <a:noFill/>
+        </p:spPr>
+        <p:txBody>
+          <a:bodyPr wrap="square" lIns="18288" rIns="18288" tIns="0" bIns="0">
+            <a:spAutoFit/>
+          </a:bodyPr>
+          <a:lstStyle/>
+          <a:p>
+            <a:pPr algn="l">
+              <a:spcAft>
+                <a:spcPts val="400"/>
+              </a:spcAft>
+              <a:defRPr sz="4900" b="1">
+                <a:solidFill>
+                  <a:srgbClr val="C05C2B"/>
+                </a:solidFill>
+                <a:latin typeface="Tahoma"/>
+              </a:defRPr>
+            </a:pPr>
+            <a:r>
+              <a:t>45</a:t>
+            </a:r>
+          </a:p>
+        </p:txBody>
+      </p:sp>
+      <p:sp>
+        <p:nvSpPr>
+          <p:cNvPr id="13" name="TextBox 12"/>
+          <p:cNvSpPr txBox="1"/>
+          <p:nvPr/>
+        </p:nvSpPr>
+        <p:spPr>
+          <a:xfrm>
+            <a:off x="4672584" y="3090672"/>
+            <a:ext cx="2816352" cy="466344"/>
+          </a:xfrm>
+          <a:prstGeom prst="rect">
+            <a:avLst/>
+          </a:prstGeom>
+          <a:noFill/>
+        </p:spPr>
+        <p:txBody>
+          <a:bodyPr wrap="square" lIns="18288" rIns="18288" tIns="0" bIns="0">
+            <a:spAutoFit/>
+          </a:bodyPr>
+          <a:lstStyle/>
+          <a:p>
+            <a:pPr algn="l">
+              <a:spcAft>
+                <a:spcPts val="400"/>
+              </a:spcAft>
+              <a:defRPr sz="2200" b="1">
+                <a:solidFill>
+                  <a:srgbClr val="1D2A5D"/>
+                </a:solidFill>
+                <a:latin typeface="Tahoma"/>
+              </a:defRPr>
+            </a:pPr>
+            <a:r>
+              <a:t>อ่านได้บางส่วน</a:t>
+            </a:r>
+          </a:p>
+        </p:txBody>
+      </p:sp>
+      <p:sp>
+        <p:nvSpPr>
+          <p:cNvPr id="14" name="TextBox 13"/>
+          <p:cNvSpPr txBox="1"/>
+          <p:nvPr/>
+        </p:nvSpPr>
+        <p:spPr>
+          <a:xfrm>
+            <a:off x="4672584" y="3703320"/>
+            <a:ext cx="2798064" cy="758952"/>
+          </a:xfrm>
+          <a:prstGeom prst="rect">
+            <a:avLst/>
+          </a:prstGeom>
+          <a:noFill/>
+        </p:spPr>
+        <p:txBody>
+          <a:bodyPr wrap="square" lIns="18288" rIns="18288" tIns="0" bIns="0">
+            <a:spAutoFit/>
+          </a:bodyPr>
+          <a:lstStyle/>
+          <a:p>
+            <a:pPr algn="l">
+              <a:spcAft>
+                <a:spcPts val="400"/>
+              </a:spcAft>
+              <a:defRPr sz="1600" b="0">
+                <a:solidFill>
+                  <a:srgbClr val="1D2F3E"/>
+                </a:solidFill>
+                <a:latin typeface="Tahoma"/>
+              </a:defRPr>
+            </a:pPr>
+            <a:r>
+              <a:t>ยังมีอย่างน้อยหนึ่งบรรทัดอ่านไม่ครบ</a:t>
+            </a:r>
+          </a:p>
+        </p:txBody>
+      </p:sp>
+      <p:sp>
+        <p:nvSpPr>
+          <p:cNvPr id="15" name="Rounded Rectangle 14"/>
           <p:cNvSpPr/>
           <p:nvPr/>
         </p:nvSpPr>
         <p:spPr>
           <a:xfrm>
-            <a:off x="914400" y="4270248"/>
-            <a:ext cx="9966960" cy="265176"/>
-          </a:xfrm>
-          <a:prstGeom prst="rect">
+            <a:off x="8165592" y="1737360"/>
+            <a:ext cx="3282696" cy="3054096"/>
+          </a:xfrm>
+          <a:prstGeom prst="roundRect">
             <a:avLst/>
           </a:prstGeom>
           <a:solidFill>
-            <a:srgbClr val="E0E9EE"/>
+            <a:srgbClr val="F2F6F8"/>
           </a:solidFill>
           <a:ln>
             <a:noFill/>
@@ -5678,57 +6236,53 @@
       </p:sp>
       <p:sp>
         <p:nvSpPr>
-          <p:cNvPr id="14" name="Rectangle 13"/>
-          <p:cNvSpPr/>
-          <p:nvPr/>
-        </p:nvSpPr>
-        <p:spPr>
-          <a:xfrm>
-            <a:off x="914400" y="4270248"/>
-            <a:ext cx="2362169" cy="265176"/>
-          </a:xfrm>
-          <a:prstGeom prst="rect">
-            <a:avLst/>
-          </a:prstGeom>
-          <a:solidFill>
-            <a:srgbClr val="C05C2B"/>
-          </a:solidFill>
-          <a:ln>
-            <a:noFill/>
-          </a:ln>
-        </p:spPr>
-        <p:style>
-          <a:lnRef idx="1">
-            <a:schemeClr val="accent1"/>
-          </a:lnRef>
-          <a:fillRef idx="3">
-            <a:schemeClr val="accent1"/>
-          </a:fillRef>
-          <a:effectRef idx="2">
-            <a:schemeClr val="accent1"/>
-          </a:effectRef>
-          <a:fontRef idx="minor">
-            <a:schemeClr val="lt1"/>
-          </a:fontRef>
-        </p:style>
-        <p:txBody>
-          <a:bodyPr rtlCol="0" anchor="ctr"/>
-          <a:lstStyle/>
-          <a:p>
-            <a:pPr algn="ctr"/>
-          </a:p>
-        </p:txBody>
-      </p:sp>
-      <p:sp>
-        <p:nvSpPr>
-          <p:cNvPr id="15" name="TextBox 14"/>
-          <p:cNvSpPr txBox="1"/>
-          <p:nvPr/>
-        </p:nvSpPr>
-        <p:spPr>
-          <a:xfrm>
-            <a:off x="914400" y="5047488"/>
-            <a:ext cx="10149840" cy="548640"/>
+          <p:cNvPr id="16" name="TextBox 15"/>
+          <p:cNvSpPr txBox="1"/>
+          <p:nvPr/>
+        </p:nvSpPr>
+        <p:spPr>
+          <a:xfrm>
+            <a:off x="8394192" y="1993392"/>
+            <a:ext cx="2834640" cy="941832"/>
+          </a:xfrm>
+          <a:prstGeom prst="rect">
+            <a:avLst/>
+          </a:prstGeom>
+          <a:noFill/>
+        </p:spPr>
+        <p:txBody>
+          <a:bodyPr wrap="square" lIns="18288" rIns="18288" tIns="0" bIns="0">
+            <a:spAutoFit/>
+          </a:bodyPr>
+          <a:lstStyle/>
+          <a:p>
+            <a:pPr algn="l">
+              <a:spcAft>
+                <a:spcPts val="400"/>
+              </a:spcAft>
+              <a:defRPr sz="4900" b="1">
+                <a:solidFill>
+                  <a:srgbClr val="006289"/>
+                </a:solidFill>
+                <a:latin typeface="Tahoma"/>
+              </a:defRPr>
+            </a:pPr>
+            <a:r>
+              <a:t>2</a:t>
+            </a:r>
+          </a:p>
+        </p:txBody>
+      </p:sp>
+      <p:sp>
+        <p:nvSpPr>
+          <p:cNvPr id="17" name="TextBox 16"/>
+          <p:cNvSpPr txBox="1"/>
+          <p:nvPr/>
+        </p:nvSpPr>
+        <p:spPr>
+          <a:xfrm>
+            <a:off x="8394192" y="3090672"/>
+            <a:ext cx="2816352" cy="466344"/>
           </a:xfrm>
           <a:prstGeom prst="rect">
             <a:avLst/>
@@ -5753,21 +6307,99 @@
               </a:defRPr>
             </a:pPr>
             <a:r>
-              <a:t>ผลต่างระหว่างชุดยังอธิบายไม่ได้ทั้งหมด</a:t>
-            </a:r>
-          </a:p>
-        </p:txBody>
-      </p:sp>
-      <p:sp>
-        <p:nvSpPr>
-          <p:cNvPr id="16" name="TextBox 15"/>
-          <p:cNvSpPr txBox="1"/>
-          <p:nvPr/>
-        </p:nvSpPr>
-        <p:spPr>
-          <a:xfrm>
-            <a:off x="914400" y="5696712"/>
-            <a:ext cx="10424160" cy="320040"/>
+              <a:t>ไม่มีบรรทัดชื่อ</a:t>
+            </a:r>
+          </a:p>
+        </p:txBody>
+      </p:sp>
+      <p:sp>
+        <p:nvSpPr>
+          <p:cNvPr id="18" name="TextBox 17"/>
+          <p:cNvSpPr txBox="1"/>
+          <p:nvPr/>
+        </p:nvSpPr>
+        <p:spPr>
+          <a:xfrm>
+            <a:off x="8394192" y="3703320"/>
+            <a:ext cx="2798064" cy="758952"/>
+          </a:xfrm>
+          <a:prstGeom prst="rect">
+            <a:avLst/>
+          </a:prstGeom>
+          <a:noFill/>
+        </p:spPr>
+        <p:txBody>
+          <a:bodyPr wrap="square" lIns="18288" rIns="18288" tIns="0" bIns="0">
+            <a:spAutoFit/>
+          </a:bodyPr>
+          <a:lstStyle/>
+          <a:p>
+            <a:pPr algn="l">
+              <a:spcAft>
+                <a:spcPts val="400"/>
+              </a:spcAft>
+              <a:defRPr sz="1600" b="0">
+                <a:solidFill>
+                  <a:srgbClr val="1D2F3E"/>
+                </a:solidFill>
+                <a:latin typeface="Tahoma"/>
+              </a:defRPr>
+            </a:pPr>
+            <a:r>
+              <a:t>ไม่มีข้อความชื่อสินค้าให้ถอด</a:t>
+            </a:r>
+          </a:p>
+        </p:txBody>
+      </p:sp>
+      <p:sp>
+        <p:nvSpPr>
+          <p:cNvPr id="19" name="TextBox 18"/>
+          <p:cNvSpPr txBox="1"/>
+          <p:nvPr/>
+        </p:nvSpPr>
+        <p:spPr>
+          <a:xfrm>
+            <a:off x="804672" y="5074920"/>
+            <a:ext cx="10634472" cy="530352"/>
+          </a:xfrm>
+          <a:prstGeom prst="rect">
+            <a:avLst/>
+          </a:prstGeom>
+          <a:noFill/>
+        </p:spPr>
+        <p:txBody>
+          <a:bodyPr wrap="square" lIns="18288" rIns="18288" tIns="0" bIns="0">
+            <a:spAutoFit/>
+          </a:bodyPr>
+          <a:lstStyle/>
+          <a:p>
+            <a:pPr algn="l">
+              <a:spcAft>
+                <a:spcPts val="400"/>
+              </a:spcAft>
+              <a:defRPr sz="1700" b="1">
+                <a:solidFill>
+                  <a:srgbClr val="1D2A5D"/>
+                </a:solidFill>
+                <a:latin typeface="Tahoma"/>
+              </a:defRPr>
+            </a:pPr>
+            <a:r>
+              <a:t>ใน 45 ภาพที่อ่านไม่ครบ มี 28 ภาพที่เก็บช่วงชื่อที่อ่านได้แน่ชัด และ 17 ภาพยังไม่มีช่วงชื่อที่ยืนยันได้</a:t>
+            </a:r>
+          </a:p>
+        </p:txBody>
+      </p:sp>
+      <p:sp>
+        <p:nvSpPr>
+          <p:cNvPr id="20" name="TextBox 19"/>
+          <p:cNvSpPr txBox="1"/>
+          <p:nvPr/>
+        </p:nvSpPr>
+        <p:spPr>
+          <a:xfrm>
+            <a:off x="804672" y="5724144"/>
+            <a:ext cx="10561320" cy="438912"/>
           </a:xfrm>
           <a:prstGeom prst="rect">
             <a:avLst/>
@@ -5792,7 +6424,7 @@
               </a:defRPr>
             </a:pPr>
             <a:r>
-              <a:t>6 ภาพไม่ได้ใช้ฝึก; ความสว่างมัธยฐานทั้งภาพ 172.5 เทียบ 122.2; ตรวจผลการหมุนหน้าถัดไป</a:t>
+              <a:t>จึงยังไม่มีสัดส่วนภาษาไทย/อังกฤษที่แทนชื่อสินค้าในทั้ง 59 ภาพ; ยังไม่มีผู้ตรวจคนที่สอง</a:t>
             </a:r>
           </a:p>
         </p:txBody>
@@ -5857,7 +6489,7 @@
               </a:defRPr>
             </a:pPr>
             <a:r>
-              <a:t>ทดสอบผลของการหมุนภาพแบบจับคู่</a:t>
+              <a:t>ผล YOLO: คะแนนนี้มาจากภาพตรวจ 16 ใบ</a:t>
             </a:r>
           </a:p>
         </p:txBody>
@@ -5896,7 +6528,7 @@
               </a:defRPr>
             </a:pPr>
             <a:r>
-              <a:t>ใช้โมเดลเดิมและภาพเดิม หมุนกรอบเฉลยตามภาพ; ไม่ฝึกเพิ่ม</a:t>
+              <a:t>ใน 59 ภาพ ใช้ 38 ฝึกโมเดล / 10 ตรวจฉากเดิม / 6 ตรวจฉากใหม่ / กันออก 5</a:t>
             </a:r>
           </a:p>
         </p:txBody>
@@ -6016,53 +6648,14 @@
       </p:sp>
       <p:sp>
         <p:nvSpPr>
-          <p:cNvPr id="7" name="TextBox 6"/>
-          <p:cNvSpPr txBox="1"/>
-          <p:nvPr/>
-        </p:nvSpPr>
-        <p:spPr>
-          <a:xfrm>
-            <a:off x="786384" y="1536192"/>
-            <a:ext cx="10652760" cy="429768"/>
-          </a:xfrm>
-          <a:prstGeom prst="rect">
-            <a:avLst/>
-          </a:prstGeom>
-          <a:noFill/>
-        </p:spPr>
-        <p:txBody>
-          <a:bodyPr wrap="square" lIns="18288" rIns="18288" tIns="0" bIns="0">
-            <a:spAutoFit/>
-          </a:bodyPr>
-          <a:lstStyle/>
-          <a:p>
-            <a:pPr algn="l">
-              <a:spcAft>
-                <a:spcPts val="400"/>
-              </a:spcAft>
-              <a:defRPr sz="1800" b="1">
-                <a:solidFill>
-                  <a:srgbClr val="1D2A5D"/>
-                </a:solidFill>
-                <a:latin typeface="Tahoma"/>
-              </a:defRPr>
-            </a:pPr>
-            <a:r>
-              <a:t>ตรวจภาพด้วยตา: ตัวหนังสือหมุนข้าง 3/10 ในชุดแรก และ 6/6 ในชุดส่งเพิ่ม</a:t>
-            </a:r>
-          </a:p>
-        </p:txBody>
-      </p:sp>
-      <p:sp>
-        <p:nvSpPr>
-          <p:cNvPr id="8" name="Rounded Rectangle 7"/>
+          <p:cNvPr id="7" name="Rounded Rectangle 6"/>
           <p:cNvSpPr/>
           <p:nvPr/>
         </p:nvSpPr>
         <p:spPr>
           <a:xfrm>
-            <a:off x="731520" y="2212848"/>
-            <a:ext cx="5212080" cy="3191256"/>
+            <a:off x="768096" y="1700784"/>
+            <a:ext cx="5120640" cy="2331720"/>
           </a:xfrm>
           <a:prstGeom prst="roundRect">
             <a:avLst/>
@@ -6098,14 +6691,252 @@
       </p:sp>
       <p:sp>
         <p:nvSpPr>
-          <p:cNvPr id="9" name="Rounded Rectangle 8"/>
+          <p:cNvPr id="8" name="Rounded Rectangle 7"/>
           <p:cNvSpPr/>
           <p:nvPr/>
         </p:nvSpPr>
         <p:spPr>
           <a:xfrm>
-            <a:off x="6217920" y="2212848"/>
-            <a:ext cx="5212080" cy="3191256"/>
+            <a:off x="6263640" y="1700784"/>
+            <a:ext cx="5120640" cy="2331720"/>
+          </a:xfrm>
+          <a:prstGeom prst="roundRect">
+            <a:avLst/>
+          </a:prstGeom>
+          <a:solidFill>
+            <a:srgbClr val="FAF0E9"/>
+          </a:solidFill>
+          <a:ln>
+            <a:noFill/>
+          </a:ln>
+        </p:spPr>
+        <p:style>
+          <a:lnRef idx="1">
+            <a:schemeClr val="accent1"/>
+          </a:lnRef>
+          <a:fillRef idx="3">
+            <a:schemeClr val="accent1"/>
+          </a:fillRef>
+          <a:effectRef idx="2">
+            <a:schemeClr val="accent1"/>
+          </a:effectRef>
+          <a:fontRef idx="minor">
+            <a:schemeClr val="lt1"/>
+          </a:fontRef>
+        </p:style>
+        <p:txBody>
+          <a:bodyPr rtlCol="0" anchor="ctr"/>
+          <a:lstStyle/>
+          <a:p>
+            <a:pPr algn="ctr"/>
+          </a:p>
+        </p:txBody>
+      </p:sp>
+      <p:sp>
+        <p:nvSpPr>
+          <p:cNvPr id="9" name="TextBox 8"/>
+          <p:cNvSpPr txBox="1"/>
+          <p:nvPr/>
+        </p:nvSpPr>
+        <p:spPr>
+          <a:xfrm>
+            <a:off x="1042415" y="1947672"/>
+            <a:ext cx="4297680" cy="832104"/>
+          </a:xfrm>
+          <a:prstGeom prst="rect">
+            <a:avLst/>
+          </a:prstGeom>
+          <a:noFill/>
+        </p:spPr>
+        <p:txBody>
+          <a:bodyPr wrap="square" lIns="18288" rIns="18288" tIns="0" bIns="0">
+            <a:spAutoFit/>
+          </a:bodyPr>
+          <a:lstStyle/>
+          <a:p>
+            <a:pPr algn="l">
+              <a:spcAft>
+                <a:spcPts val="400"/>
+              </a:spcAft>
+              <a:defRPr sz="4400" b="1">
+                <a:solidFill>
+                  <a:srgbClr val="137E9A"/>
+                </a:solidFill>
+                <a:latin typeface="Tahoma"/>
+              </a:defRPr>
+            </a:pPr>
+            <a:r>
+              <a:t>0.928</a:t>
+            </a:r>
+          </a:p>
+        </p:txBody>
+      </p:sp>
+      <p:sp>
+        <p:nvSpPr>
+          <p:cNvPr id="10" name="TextBox 9"/>
+          <p:cNvSpPr txBox="1"/>
+          <p:nvPr/>
+        </p:nvSpPr>
+        <p:spPr>
+          <a:xfrm>
+            <a:off x="1060704" y="3044952"/>
+            <a:ext cx="4407408" cy="457200"/>
+          </a:xfrm>
+          <a:prstGeom prst="rect">
+            <a:avLst/>
+          </a:prstGeom>
+          <a:noFill/>
+        </p:spPr>
+        <p:txBody>
+          <a:bodyPr wrap="square" lIns="18288" rIns="18288" tIns="0" bIns="0">
+            <a:spAutoFit/>
+          </a:bodyPr>
+          <a:lstStyle/>
+          <a:p>
+            <a:pPr algn="l">
+              <a:spcAft>
+                <a:spcPts val="400"/>
+              </a:spcAft>
+              <a:defRPr sz="2100" b="1">
+                <a:solidFill>
+                  <a:srgbClr val="1D2A5D"/>
+                </a:solidFill>
+                <a:latin typeface="Tahoma"/>
+              </a:defRPr>
+            </a:pPr>
+            <a:r>
+              <a:t>10 ภาพฉากเดิม</a:t>
+            </a:r>
+          </a:p>
+        </p:txBody>
+      </p:sp>
+      <p:sp>
+        <p:nvSpPr>
+          <p:cNvPr id="11" name="TextBox 10"/>
+          <p:cNvSpPr txBox="1"/>
+          <p:nvPr/>
+        </p:nvSpPr>
+        <p:spPr>
+          <a:xfrm>
+            <a:off x="6537960" y="1947672"/>
+            <a:ext cx="4297680" cy="832104"/>
+          </a:xfrm>
+          <a:prstGeom prst="rect">
+            <a:avLst/>
+          </a:prstGeom>
+          <a:noFill/>
+        </p:spPr>
+        <p:txBody>
+          <a:bodyPr wrap="square" lIns="18288" rIns="18288" tIns="0" bIns="0">
+            <a:spAutoFit/>
+          </a:bodyPr>
+          <a:lstStyle/>
+          <a:p>
+            <a:pPr algn="l">
+              <a:spcAft>
+                <a:spcPts val="400"/>
+              </a:spcAft>
+              <a:defRPr sz="4400" b="1">
+                <a:solidFill>
+                  <a:srgbClr val="C05C2B"/>
+                </a:solidFill>
+                <a:latin typeface="Tahoma"/>
+              </a:defRPr>
+            </a:pPr>
+            <a:r>
+              <a:t>0.237</a:t>
+            </a:r>
+          </a:p>
+        </p:txBody>
+      </p:sp>
+      <p:sp>
+        <p:nvSpPr>
+          <p:cNvPr id="12" name="TextBox 11"/>
+          <p:cNvSpPr txBox="1"/>
+          <p:nvPr/>
+        </p:nvSpPr>
+        <p:spPr>
+          <a:xfrm>
+            <a:off x="6556248" y="3044952"/>
+            <a:ext cx="4407408" cy="457200"/>
+          </a:xfrm>
+          <a:prstGeom prst="rect">
+            <a:avLst/>
+          </a:prstGeom>
+          <a:noFill/>
+        </p:spPr>
+        <p:txBody>
+          <a:bodyPr wrap="square" lIns="18288" rIns="18288" tIns="0" bIns="0">
+            <a:spAutoFit/>
+          </a:bodyPr>
+          <a:lstStyle/>
+          <a:p>
+            <a:pPr algn="l">
+              <a:spcAft>
+                <a:spcPts val="400"/>
+              </a:spcAft>
+              <a:defRPr sz="2100" b="1">
+                <a:solidFill>
+                  <a:srgbClr val="1D2A5D"/>
+                </a:solidFill>
+                <a:latin typeface="Tahoma"/>
+              </a:defRPr>
+            </a:pPr>
+            <a:r>
+              <a:t>6 ภาพฉากใหม่</a:t>
+            </a:r>
+          </a:p>
+        </p:txBody>
+      </p:sp>
+      <p:sp>
+        <p:nvSpPr>
+          <p:cNvPr id="13" name="TextBox 12"/>
+          <p:cNvSpPr txBox="1"/>
+          <p:nvPr/>
+        </p:nvSpPr>
+        <p:spPr>
+          <a:xfrm>
+            <a:off x="850392" y="4315968"/>
+            <a:ext cx="10515600" cy="457200"/>
+          </a:xfrm>
+          <a:prstGeom prst="rect">
+            <a:avLst/>
+          </a:prstGeom>
+          <a:noFill/>
+        </p:spPr>
+        <p:txBody>
+          <a:bodyPr wrap="square" lIns="18288" rIns="18288" tIns="0" bIns="0">
+            <a:spAutoFit/>
+          </a:bodyPr>
+          <a:lstStyle/>
+          <a:p>
+            <a:pPr algn="l">
+              <a:spcAft>
+                <a:spcPts val="400"/>
+              </a:spcAft>
+              <a:defRPr sz="2000" b="1">
+                <a:solidFill>
+                  <a:srgbClr val="1D2A5D"/>
+                </a:solidFill>
+                <a:latin typeface="Tahoma"/>
+              </a:defRPr>
+            </a:pPr>
+            <a:r>
+              <a:t>mAP@0.5: คะแนนเฉลี่ยการหากรอบ 0–1; สูงดีกว่า</a:t>
+            </a:r>
+          </a:p>
+        </p:txBody>
+      </p:sp>
+      <p:sp>
+        <p:nvSpPr>
+          <p:cNvPr id="14" name="Rounded Rectangle 13"/>
+          <p:cNvSpPr/>
+          <p:nvPr/>
+        </p:nvSpPr>
+        <p:spPr>
+          <a:xfrm>
+            <a:off x="786384" y="4965192"/>
+            <a:ext cx="10607040" cy="667512"/>
           </a:xfrm>
           <a:prstGeom prst="roundRect">
             <a:avLst/>
@@ -6141,109 +6972,70 @@
       </p:sp>
       <p:sp>
         <p:nvSpPr>
-          <p:cNvPr id="10" name="TextBox 9"/>
-          <p:cNvSpPr txBox="1"/>
-          <p:nvPr/>
-        </p:nvSpPr>
-        <p:spPr>
-          <a:xfrm>
-            <a:off x="996696" y="2505456"/>
-            <a:ext cx="4590288" cy="393192"/>
-          </a:xfrm>
-          <a:prstGeom prst="rect">
-            <a:avLst/>
-          </a:prstGeom>
-          <a:noFill/>
-        </p:spPr>
-        <p:txBody>
-          <a:bodyPr wrap="square" lIns="18288" rIns="18288" tIns="0" bIns="0">
-            <a:spAutoFit/>
-          </a:bodyPr>
-          <a:lstStyle/>
-          <a:p>
-            <a:pPr algn="l">
-              <a:spcAft>
-                <a:spcPts val="400"/>
-              </a:spcAft>
-              <a:defRPr sz="1900" b="1">
-                <a:solidFill>
-                  <a:srgbClr val="1D2A5D"/>
-                </a:solidFill>
-                <a:latin typeface="Tahoma"/>
-              </a:defRPr>
-            </a:pPr>
-            <a:r>
-              <a:t>7 ภาพจากชุดแรกที่อ่านตรง</a:t>
-            </a:r>
-          </a:p>
-        </p:txBody>
-      </p:sp>
-      <p:sp>
-        <p:nvSpPr>
-          <p:cNvPr id="11" name="TextBox 10"/>
-          <p:cNvSpPr txBox="1"/>
-          <p:nvPr/>
-        </p:nvSpPr>
-        <p:spPr>
-          <a:xfrm>
-            <a:off x="1033271" y="3145536"/>
-            <a:ext cx="1664208" cy="658368"/>
-          </a:xfrm>
-          <a:prstGeom prst="rect">
-            <a:avLst/>
-          </a:prstGeom>
-          <a:noFill/>
-        </p:spPr>
-        <p:txBody>
-          <a:bodyPr wrap="square" lIns="18288" rIns="18288" tIns="0" bIns="0">
-            <a:spAutoFit/>
-          </a:bodyPr>
-          <a:lstStyle/>
-          <a:p>
-            <a:pPr algn="l">
-              <a:spcAft>
-                <a:spcPts val="400"/>
-              </a:spcAft>
-              <a:defRPr sz="3400" b="1">
-                <a:solidFill>
-                  <a:srgbClr val="137E9A"/>
-                </a:solidFill>
-                <a:latin typeface="Tahoma"/>
-              </a:defRPr>
-            </a:pPr>
-            <a:r>
-              <a:t>0.995</a:t>
-            </a:r>
-          </a:p>
-        </p:txBody>
-      </p:sp>
-      <p:sp>
-        <p:nvSpPr>
-          <p:cNvPr id="12" name="TextBox 11"/>
-          <p:cNvSpPr txBox="1"/>
-          <p:nvPr/>
-        </p:nvSpPr>
-        <p:spPr>
-          <a:xfrm>
-            <a:off x="2843784" y="3227832"/>
-            <a:ext cx="512064" cy="448056"/>
-          </a:xfrm>
-          <a:prstGeom prst="rect">
-            <a:avLst/>
-          </a:prstGeom>
-          <a:noFill/>
-        </p:spPr>
-        <p:txBody>
-          <a:bodyPr wrap="square" lIns="18288" rIns="18288" tIns="0" bIns="0">
-            <a:spAutoFit/>
-          </a:bodyPr>
-          <a:lstStyle/>
-          <a:p>
-            <a:pPr algn="ctr">
-              <a:spcAft>
-                <a:spcPts val="400"/>
-              </a:spcAft>
-              <a:defRPr sz="2400" b="1">
+          <p:cNvPr id="15" name="TextBox 14"/>
+          <p:cNvSpPr txBox="1"/>
+          <p:nvPr/>
+        </p:nvSpPr>
+        <p:spPr>
+          <a:xfrm>
+            <a:off x="987552" y="5120640"/>
+            <a:ext cx="10149840" cy="338328"/>
+          </a:xfrm>
+          <a:prstGeom prst="rect">
+            <a:avLst/>
+          </a:prstGeom>
+          <a:noFill/>
+        </p:spPr>
+        <p:txBody>
+          <a:bodyPr wrap="square" lIns="18288" rIns="18288" tIns="0" bIns="0">
+            <a:spAutoFit/>
+          </a:bodyPr>
+          <a:lstStyle/>
+          <a:p>
+            <a:pPr algn="l">
+              <a:spcAft>
+                <a:spcPts val="400"/>
+              </a:spcAft>
+              <a:defRPr sz="1800" b="1">
+                <a:solidFill>
+                  <a:srgbClr val="006289"/>
+                </a:solidFill>
+                <a:latin typeface="Tahoma"/>
+              </a:defRPr>
+            </a:pPr>
+            <a:r>
+              <a:t>ลองหมุน 6 ภาพฉากใหม่ให้อ่านตรงด้วยโมเดลเดิม: 0.237 → 0.714</a:t>
+            </a:r>
+          </a:p>
+        </p:txBody>
+      </p:sp>
+      <p:sp>
+        <p:nvSpPr>
+          <p:cNvPr id="16" name="TextBox 15"/>
+          <p:cNvSpPr txBox="1"/>
+          <p:nvPr/>
+        </p:nvSpPr>
+        <p:spPr>
+          <a:xfrm>
+            <a:off x="832104" y="5888736"/>
+            <a:ext cx="10515600" cy="338328"/>
+          </a:xfrm>
+          <a:prstGeom prst="rect">
+            <a:avLst/>
+          </a:prstGeom>
+          <a:noFill/>
+        </p:spPr>
+        <p:txBody>
+          <a:bodyPr wrap="square" lIns="18288" rIns="18288" tIns="0" bIns="0">
+            <a:spAutoFit/>
+          </a:bodyPr>
+          <a:lstStyle/>
+          <a:p>
+            <a:pPr algn="l">
+              <a:spcAft>
+                <a:spcPts val="400"/>
+              </a:spcAft>
+              <a:defRPr sz="1400" b="0">
                 <a:solidFill>
                   <a:srgbClr val="576975"/>
                 </a:solidFill>
@@ -6251,475 +7043,7 @@
               </a:defRPr>
             </a:pPr>
             <a:r>
-              <a:t>→</a:t>
-            </a:r>
-          </a:p>
-        </p:txBody>
-      </p:sp>
-      <p:sp>
-        <p:nvSpPr>
-          <p:cNvPr id="13" name="TextBox 12"/>
-          <p:cNvSpPr txBox="1"/>
-          <p:nvPr/>
-        </p:nvSpPr>
-        <p:spPr>
-          <a:xfrm>
-            <a:off x="3529584" y="3145536"/>
-            <a:ext cx="2011680" cy="658368"/>
-          </a:xfrm>
-          <a:prstGeom prst="rect">
-            <a:avLst/>
-          </a:prstGeom>
-          <a:noFill/>
-        </p:spPr>
-        <p:txBody>
-          <a:bodyPr wrap="square" lIns="18288" rIns="18288" tIns="0" bIns="0">
-            <a:spAutoFit/>
-          </a:bodyPr>
-          <a:lstStyle/>
-          <a:p>
-            <a:pPr algn="l">
-              <a:spcAft>
-                <a:spcPts val="400"/>
-              </a:spcAft>
-              <a:defRPr sz="3400" b="1">
-                <a:solidFill>
-                  <a:srgbClr val="C05C2B"/>
-                </a:solidFill>
-                <a:latin typeface="Tahoma"/>
-              </a:defRPr>
-            </a:pPr>
-            <a:r>
-              <a:t>0.492</a:t>
-            </a:r>
-          </a:p>
-        </p:txBody>
-      </p:sp>
-      <p:sp>
-        <p:nvSpPr>
-          <p:cNvPr id="14" name="TextBox 13"/>
-          <p:cNvSpPr txBox="1"/>
-          <p:nvPr/>
-        </p:nvSpPr>
-        <p:spPr>
-          <a:xfrm>
-            <a:off x="1024128" y="3968496"/>
-            <a:ext cx="1828800" cy="338328"/>
-          </a:xfrm>
-          <a:prstGeom prst="rect">
-            <a:avLst/>
-          </a:prstGeom>
-          <a:noFill/>
-        </p:spPr>
-        <p:txBody>
-          <a:bodyPr wrap="square" lIns="18288" rIns="18288" tIns="0" bIns="0">
-            <a:spAutoFit/>
-          </a:bodyPr>
-          <a:lstStyle/>
-          <a:p>
-            <a:pPr algn="l">
-              <a:spcAft>
-                <a:spcPts val="400"/>
-              </a:spcAft>
-              <a:defRPr sz="1600" b="0">
-                <a:solidFill>
-                  <a:srgbClr val="1D2F3E"/>
-                </a:solidFill>
-                <a:latin typeface="Tahoma"/>
-              </a:defRPr>
-            </a:pPr>
-            <a:r>
-              <a:t>ต้นฉบับ</a:t>
-            </a:r>
-          </a:p>
-        </p:txBody>
-      </p:sp>
-      <p:sp>
-        <p:nvSpPr>
-          <p:cNvPr id="15" name="TextBox 14"/>
-          <p:cNvSpPr txBox="1"/>
-          <p:nvPr/>
-        </p:nvSpPr>
-        <p:spPr>
-          <a:xfrm>
-            <a:off x="3529584" y="3968496"/>
-            <a:ext cx="1828800" cy="338328"/>
-          </a:xfrm>
-          <a:prstGeom prst="rect">
-            <a:avLst/>
-          </a:prstGeom>
-          <a:noFill/>
-        </p:spPr>
-        <p:txBody>
-          <a:bodyPr wrap="square" lIns="18288" rIns="18288" tIns="0" bIns="0">
-            <a:spAutoFit/>
-          </a:bodyPr>
-          <a:lstStyle/>
-          <a:p>
-            <a:pPr algn="l">
-              <a:spcAft>
-                <a:spcPts val="400"/>
-              </a:spcAft>
-              <a:defRPr sz="1600" b="0">
-                <a:solidFill>
-                  <a:srgbClr val="1D2F3E"/>
-                </a:solidFill>
-                <a:latin typeface="Tahoma"/>
-              </a:defRPr>
-            </a:pPr>
-            <a:r>
-              <a:t>หมุน 90°</a:t>
-            </a:r>
-          </a:p>
-        </p:txBody>
-      </p:sp>
-      <p:sp>
-        <p:nvSpPr>
-          <p:cNvPr id="16" name="TextBox 15"/>
-          <p:cNvSpPr txBox="1"/>
-          <p:nvPr/>
-        </p:nvSpPr>
-        <p:spPr>
-          <a:xfrm>
-            <a:off x="1005840" y="4645152"/>
-            <a:ext cx="4608576" cy="411480"/>
-          </a:xfrm>
-          <a:prstGeom prst="rect">
-            <a:avLst/>
-          </a:prstGeom>
-          <a:noFill/>
-        </p:spPr>
-        <p:txBody>
-          <a:bodyPr wrap="square" lIns="18288" rIns="18288" tIns="0" bIns="0">
-            <a:spAutoFit/>
-          </a:bodyPr>
-          <a:lstStyle/>
-          <a:p>
-            <a:pPr algn="l">
-              <a:spcAft>
-                <a:spcPts val="400"/>
-              </a:spcAft>
-              <a:defRPr sz="1700" b="1">
-                <a:solidFill>
-                  <a:srgbClr val="1D2A5D"/>
-                </a:solidFill>
-                <a:latin typeface="Tahoma"/>
-              </a:defRPr>
-            </a:pPr>
-            <a:r>
-              <a:t>mAP@0.5 ลดลงเมื่อหมุนภาพเดิม</a:t>
-            </a:r>
-          </a:p>
-        </p:txBody>
-      </p:sp>
-      <p:sp>
-        <p:nvSpPr>
-          <p:cNvPr id="17" name="TextBox 16"/>
-          <p:cNvSpPr txBox="1"/>
-          <p:nvPr/>
-        </p:nvSpPr>
-        <p:spPr>
-          <a:xfrm>
-            <a:off x="6483096" y="2505456"/>
-            <a:ext cx="4590288" cy="393192"/>
-          </a:xfrm>
-          <a:prstGeom prst="rect">
-            <a:avLst/>
-          </a:prstGeom>
-          <a:noFill/>
-        </p:spPr>
-        <p:txBody>
-          <a:bodyPr wrap="square" lIns="18288" rIns="18288" tIns="0" bIns="0">
-            <a:spAutoFit/>
-          </a:bodyPr>
-          <a:lstStyle/>
-          <a:p>
-            <a:pPr algn="l">
-              <a:spcAft>
-                <a:spcPts val="400"/>
-              </a:spcAft>
-              <a:defRPr sz="1900" b="1">
-                <a:solidFill>
-                  <a:srgbClr val="1D2A5D"/>
-                </a:solidFill>
-                <a:latin typeface="Tahoma"/>
-              </a:defRPr>
-            </a:pPr>
-            <a:r>
-              <a:t>6 ภาพที่ส่งเพิ่ม (เดิมหมุนข้าง)</a:t>
-            </a:r>
-          </a:p>
-        </p:txBody>
-      </p:sp>
-      <p:sp>
-        <p:nvSpPr>
-          <p:cNvPr id="18" name="TextBox 17"/>
-          <p:cNvSpPr txBox="1"/>
-          <p:nvPr/>
-        </p:nvSpPr>
-        <p:spPr>
-          <a:xfrm>
-            <a:off x="6519672" y="3145536"/>
-            <a:ext cx="1664208" cy="658368"/>
-          </a:xfrm>
-          <a:prstGeom prst="rect">
-            <a:avLst/>
-          </a:prstGeom>
-          <a:noFill/>
-        </p:spPr>
-        <p:txBody>
-          <a:bodyPr wrap="square" lIns="18288" rIns="18288" tIns="0" bIns="0">
-            <a:spAutoFit/>
-          </a:bodyPr>
-          <a:lstStyle/>
-          <a:p>
-            <a:pPr algn="l">
-              <a:spcAft>
-                <a:spcPts val="400"/>
-              </a:spcAft>
-              <a:defRPr sz="3400" b="1">
-                <a:solidFill>
-                  <a:srgbClr val="C05C2B"/>
-                </a:solidFill>
-                <a:latin typeface="Tahoma"/>
-              </a:defRPr>
-            </a:pPr>
-            <a:r>
-              <a:t>0.237</a:t>
-            </a:r>
-          </a:p>
-        </p:txBody>
-      </p:sp>
-      <p:sp>
-        <p:nvSpPr>
-          <p:cNvPr id="19" name="TextBox 18"/>
-          <p:cNvSpPr txBox="1"/>
-          <p:nvPr/>
-        </p:nvSpPr>
-        <p:spPr>
-          <a:xfrm>
-            <a:off x="8330183" y="3227832"/>
-            <a:ext cx="512064" cy="448056"/>
-          </a:xfrm>
-          <a:prstGeom prst="rect">
-            <a:avLst/>
-          </a:prstGeom>
-          <a:noFill/>
-        </p:spPr>
-        <p:txBody>
-          <a:bodyPr wrap="square" lIns="18288" rIns="18288" tIns="0" bIns="0">
-            <a:spAutoFit/>
-          </a:bodyPr>
-          <a:lstStyle/>
-          <a:p>
-            <a:pPr algn="ctr">
-              <a:spcAft>
-                <a:spcPts val="400"/>
-              </a:spcAft>
-              <a:defRPr sz="2400" b="1">
-                <a:solidFill>
-                  <a:srgbClr val="576975"/>
-                </a:solidFill>
-                <a:latin typeface="Tahoma"/>
-              </a:defRPr>
-            </a:pPr>
-            <a:r>
-              <a:t>→</a:t>
-            </a:r>
-          </a:p>
-        </p:txBody>
-      </p:sp>
-      <p:sp>
-        <p:nvSpPr>
-          <p:cNvPr id="20" name="TextBox 19"/>
-          <p:cNvSpPr txBox="1"/>
-          <p:nvPr/>
-        </p:nvSpPr>
-        <p:spPr>
-          <a:xfrm>
-            <a:off x="9015984" y="3145536"/>
-            <a:ext cx="2011680" cy="658368"/>
-          </a:xfrm>
-          <a:prstGeom prst="rect">
-            <a:avLst/>
-          </a:prstGeom>
-          <a:noFill/>
-        </p:spPr>
-        <p:txBody>
-          <a:bodyPr wrap="square" lIns="18288" rIns="18288" tIns="0" bIns="0">
-            <a:spAutoFit/>
-          </a:bodyPr>
-          <a:lstStyle/>
-          <a:p>
-            <a:pPr algn="l">
-              <a:spcAft>
-                <a:spcPts val="400"/>
-              </a:spcAft>
-              <a:defRPr sz="3400" b="1">
-                <a:solidFill>
-                  <a:srgbClr val="137E9A"/>
-                </a:solidFill>
-                <a:latin typeface="Tahoma"/>
-              </a:defRPr>
-            </a:pPr>
-            <a:r>
-              <a:t>0.714</a:t>
-            </a:r>
-          </a:p>
-        </p:txBody>
-      </p:sp>
-      <p:sp>
-        <p:nvSpPr>
-          <p:cNvPr id="21" name="TextBox 20"/>
-          <p:cNvSpPr txBox="1"/>
-          <p:nvPr/>
-        </p:nvSpPr>
-        <p:spPr>
-          <a:xfrm>
-            <a:off x="6510528" y="3968496"/>
-            <a:ext cx="1828800" cy="338328"/>
-          </a:xfrm>
-          <a:prstGeom prst="rect">
-            <a:avLst/>
-          </a:prstGeom>
-          <a:noFill/>
-        </p:spPr>
-        <p:txBody>
-          <a:bodyPr wrap="square" lIns="18288" rIns="18288" tIns="0" bIns="0">
-            <a:spAutoFit/>
-          </a:bodyPr>
-          <a:lstStyle/>
-          <a:p>
-            <a:pPr algn="l">
-              <a:spcAft>
-                <a:spcPts val="400"/>
-              </a:spcAft>
-              <a:defRPr sz="1600" b="0">
-                <a:solidFill>
-                  <a:srgbClr val="1D2F3E"/>
-                </a:solidFill>
-                <a:latin typeface="Tahoma"/>
-              </a:defRPr>
-            </a:pPr>
-            <a:r>
-              <a:t>ภาพเดิม</a:t>
-            </a:r>
-          </a:p>
-        </p:txBody>
-      </p:sp>
-      <p:sp>
-        <p:nvSpPr>
-          <p:cNvPr id="22" name="TextBox 21"/>
-          <p:cNvSpPr txBox="1"/>
-          <p:nvPr/>
-        </p:nvSpPr>
-        <p:spPr>
-          <a:xfrm>
-            <a:off x="9015984" y="3968496"/>
-            <a:ext cx="2121408" cy="475488"/>
-          </a:xfrm>
-          <a:prstGeom prst="rect">
-            <a:avLst/>
-          </a:prstGeom>
-          <a:noFill/>
-        </p:spPr>
-        <p:txBody>
-          <a:bodyPr wrap="square" lIns="18288" rIns="18288" tIns="0" bIns="0">
-            <a:spAutoFit/>
-          </a:bodyPr>
-          <a:lstStyle/>
-          <a:p>
-            <a:pPr algn="l">
-              <a:spcAft>
-                <a:spcPts val="400"/>
-              </a:spcAft>
-              <a:defRPr sz="1600" b="0">
-                <a:solidFill>
-                  <a:srgbClr val="1D2F3E"/>
-                </a:solidFill>
-                <a:latin typeface="Tahoma"/>
-              </a:defRPr>
-            </a:pPr>
-            <a:r>
-              <a:t>หมุนกลับให้อ่านตรง</a:t>
-            </a:r>
-          </a:p>
-        </p:txBody>
-      </p:sp>
-      <p:sp>
-        <p:nvSpPr>
-          <p:cNvPr id="23" name="TextBox 22"/>
-          <p:cNvSpPr txBox="1"/>
-          <p:nvPr/>
-        </p:nvSpPr>
-        <p:spPr>
-          <a:xfrm>
-            <a:off x="6492240" y="4645152"/>
-            <a:ext cx="4608576" cy="411480"/>
-          </a:xfrm>
-          <a:prstGeom prst="rect">
-            <a:avLst/>
-          </a:prstGeom>
-          <a:noFill/>
-        </p:spPr>
-        <p:txBody>
-          <a:bodyPr wrap="square" lIns="18288" rIns="18288" tIns="0" bIns="0">
-            <a:spAutoFit/>
-          </a:bodyPr>
-          <a:lstStyle/>
-          <a:p>
-            <a:pPr algn="l">
-              <a:spcAft>
-                <a:spcPts val="400"/>
-              </a:spcAft>
-              <a:defRPr sz="1700" b="1">
-                <a:solidFill>
-                  <a:srgbClr val="1D2A5D"/>
-                </a:solidFill>
-                <a:latin typeface="Tahoma"/>
-              </a:defRPr>
-            </a:pPr>
-            <a:r>
-              <a:t>mAP@0.5 เพิ่มขึ้นโดยไม่ฝึกเพิ่ม</a:t>
-            </a:r>
-          </a:p>
-        </p:txBody>
-      </p:sp>
-      <p:sp>
-        <p:nvSpPr>
-          <p:cNvPr id="24" name="TextBox 23"/>
-          <p:cNvSpPr txBox="1"/>
-          <p:nvPr/>
-        </p:nvSpPr>
-        <p:spPr>
-          <a:xfrm>
-            <a:off x="804672" y="5769864"/>
-            <a:ext cx="10616184" cy="438912"/>
-          </a:xfrm>
-          <a:prstGeom prst="rect">
-            <a:avLst/>
-          </a:prstGeom>
-          <a:noFill/>
-        </p:spPr>
-        <p:txBody>
-          <a:bodyPr wrap="square" lIns="18288" rIns="18288" tIns="0" bIns="0">
-            <a:spAutoFit/>
-          </a:bodyPr>
-          <a:lstStyle/>
-          <a:p>
-            <a:pPr algn="l">
-              <a:spcAft>
-                <a:spcPts val="400"/>
-              </a:spcAft>
-              <a:defRPr sz="1600" b="0">
-                <a:solidFill>
-                  <a:srgbClr val="576975"/>
-                </a:solidFill>
-                <a:latin typeface="Tahoma"/>
-              </a:defRPr>
-            </a:pPr>
-            <a:r>
-              <a:t>ผลนี้ชี้ความไวต่อการหมุนในชุดเล็ก ยังไม่พิสูจน์ว่านี่เป็นสาเหตุเดียวของคะแนนต่างระหว่างชุด</a:t>
+              <a:t>ผลต่างเกี่ยวกับทิศภาพ แต่ฉากและแสงก็ต่างกัน; ยังสรุปความแม่นยำของทั้ง 59 ภาพไม่ได้</a:t>
             </a:r>
           </a:p>
         </p:txBody>

</xml_diff>

<commit_message>
Audit Ass5 and Ass6 against sources and correct evidence claims
</commit_message>
<xml_diff>
--- a/ass5_output/Residential_Intelligence_Project_Progress_READY_2026-10-18.pptx
+++ b/ass5_output/Residential_Intelligence_Project_Progress_READY_2026-10-18.pptx
@@ -5649,7 +5649,7 @@
               </a:defRPr>
             </a:pPr>
             <a:r>
-              <a:t>ตรวจทั้ง 59 ภาพแล้ว: ชื่อสินค้าถอดครบ 12 | อ่านได้บางส่วน 45 | ไม่มีบรรทัดชื่อ 2</a:t>
+              <a:t>ตรวจทั้ง 59 ภาพแล้ว: ชื่อสินค้าถอดครบ 12 | ถอดไม่ครบ 45 | ไม่มีบรรทัดชื่อ 2</a:t>
             </a:r>
           </a:p>
         </p:txBody>
@@ -6147,7 +6147,7 @@
               </a:defRPr>
             </a:pPr>
             <a:r>
-              <a:t>อ่านได้บางส่วน</a:t>
+              <a:t>ถอดไม่ครบ</a:t>
             </a:r>
           </a:p>
         </p:txBody>
@@ -6186,7 +6186,7 @@
               </a:defRPr>
             </a:pPr>
             <a:r>
-              <a:t>ยังมีอย่างน้อยหนึ่งบรรทัดอ่านไม่ครบ</a:t>
+              <a:t>28 ภาพอ่านได้บางช่วง; 17 ยังยืนยันไม่ได้</a:t>
             </a:r>
           </a:p>
         </p:txBody>
@@ -12505,7 +12505,7 @@
               </a:defRPr>
             </a:pPr>
             <a:r>
-              <a:t>ผ่านเกณฑ์ Scopus เบื้องต้น</a:t>
+              <a:t>สถานะ Scopus เบื้องต้น</a:t>
             </a:r>
           </a:p>
         </p:txBody>
@@ -12626,7 +12626,7 @@
               </a:defRPr>
             </a:pPr>
             <a:r>
-              <a:t>ยืนยันสถานะแล้ว</a:t>
+              <a:t>คงไว้หลังตรวจซ้ำ (มีข้อสงวน 1)</a:t>
             </a:r>
           </a:p>
         </p:txBody>
@@ -12786,7 +12786,7 @@
               </a:defRPr>
             </a:pPr>
             <a:r>
-              <a:t>12 ฉบับถูกจัดตามสามมิติของกรอบ Performance Trade-off; อีก 1 ฉบับใช้สนับสนุนข้ามศาสตร์</a:t>
+              <a:t>บทความ 12 ฉบับรวม P5 ที่ใช้สนับสนุนข้ามศาสตร์; อีก 11 ฉบับอยู่ในกรอบสามมิติ</a:t>
             </a:r>
           </a:p>
         </p:txBody>

</xml_diff>